<commit_message>
Apply 20 poster + slide improvements
Template: panel labels A-D, instructional captions, title guidance,
delete-brackets reminder. Filled example: concise title, fixed n
mismatch, corrected Alfaro citation, trimmed Intro/Methods/Discussion/
Conclusions, added Main Takeaway callout. TA slides: fixed checkmark
glyphs, suppressed auto figure numbering.

Co-Authored-By: Claude Opus 4.6 (1M context) <noreply@anthropic.com>
</commit_message>
<xml_diff>
--- a/recipes-instructor-chaetodontidae/poster/poster-template-48x36-chaet-filled.pptx
+++ b/recipes-instructor-chaetodontidae/poster/poster-template-48x36-chaet-filled.pptx
@@ -3196,7 +3196,7 @@
                 </a:solidFill>
                 <a:latin typeface="Calibri"/>
               </a:rPr>
-              <a:t>Color Pattern Evolution in Butterflyfishes (Chaetodontidae): Phylogenetic Signal, Morphospace Structure, and Ecological Correlates</a:t>
+              <a:t>Butterflyfish Color Patterns Show Phylogenetic Structure and Weak Ecological Prediction</a:t>
             </a:r>
           </a:p>
         </p:txBody>
@@ -3464,7 +3464,7 @@
                 </a:solidFill>
                 <a:latin typeface="Calibri"/>
               </a:rPr>
-              <a:t>• Butterflyfishes (Chaetodontidae) are among the most colorful and recognizable reef fish families, with ~130 species displaying striking diversity in stripe patterns, eyespots, and body coloration.</a:t>
+              <a:t>• Butterflyfishes (Chaetodontidae, ~130 species) display striking diversity in stripe patterns, eyespots, and body coloration on coral reefs.</a:t>
             </a:r>
           </a:p>
           <a:p>
@@ -3480,7 +3480,7 @@
                 </a:solidFill>
                 <a:latin typeface="Calibri"/>
               </a:rPr>
-              <a:t>• Color patterns in reef fishes serve multiple functions including species recognition, predator deterrence, and camouflage, yet the evolutionary drivers of this diversity remain poorly understood.</a:t>
+              <a:t>• Color patterns may serve species recognition, predator deterrence, or camouflage, but the evolutionary drivers remain poorly understood.</a:t>
             </a:r>
           </a:p>
           <a:p>
@@ -3496,23 +3496,7 @@
                 </a:solidFill>
                 <a:latin typeface="Calibri"/>
               </a:rPr>
-              <a:t>• Phylogenetic comparative methods allow us to test whether color-pattern variation is structured by evolutionary history (phylogenetic signal) and whether ecological traits predict color diversity.</a:t>
-            </a:r>
-          </a:p>
-          <a:p>
-            <a:pPr algn="l">
-              <a:spcBef>
-                <a:spcPts val="600"/>
-              </a:spcBef>
-            </a:pPr>
-            <a:r>
-              <a:rPr sz="2400" b="0" i="0">
-                <a:solidFill>
-                  <a:srgbClr val="333333"/>
-                </a:solidFill>
-                <a:latin typeface="Calibri"/>
-              </a:rPr>
-              <a:t>• We used digital image analysis (pavo) and phylogenetic comparative methods to quantify and analyze color-pattern evolution across 109 butterflyfish species.</a:t>
+              <a:t>• We quantified color patterns with digital image analysis (pavo) and tested for phylogenetic structure and ecological prediction using comparative methods. 130 exemplar images were analyzed; 109 species were retained after matching to the time-calibrated phylogeny.</a:t>
             </a:r>
           </a:p>
         </p:txBody>
@@ -3915,7 +3899,7 @@
                 </a:solidFill>
                 <a:latin typeface="Calibri"/>
               </a:rPr>
-              <a:t>• Exemplar images for 130 species were analyzed using the R package pavo to extract adjacency-based color-pattern metrics (transition density, color diversity, boundary strength).</a:t>
+              <a:t>• 130 exemplar images analyzed with pavo; 109 species matched to tree</a:t>
             </a:r>
           </a:p>
           <a:p>
@@ -3931,7 +3915,7 @@
                 </a:solidFill>
                 <a:latin typeface="Calibri"/>
               </a:rPr>
-              <a:t>• A phylogenetic PCA (phytools::phyl.pca) reduced 10 pavo metrics to orthogonal axes; PC1 captured pattern density (39.5% variance), PC2 captured color diversity (19.2%).</a:t>
+              <a:t>• PhyloPCA reduced 10 adjacency metrics to orthogonal axes (PC1: 39.5%, PC2: 19.2%)</a:t>
             </a:r>
           </a:p>
           <a:p>
@@ -3947,7 +3931,7 @@
                 </a:solidFill>
                 <a:latin typeface="Calibri"/>
               </a:rPr>
-              <a:t>• Phylogenetic signal was assessed with Blomberg’s K on each PC axis.</a:t>
+              <a:t>• Blomberg’s K assessed phylogenetic signal per PC axis</a:t>
             </a:r>
           </a:p>
           <a:p>
@@ -3963,7 +3947,7 @@
                 </a:solidFill>
                 <a:latin typeface="Calibri"/>
               </a:rPr>
-              <a:t>• Ancestral states were reconstructed using phytools::contMap under Brownian motion.</a:t>
+              <a:t>• PGLS (nlme::gls, Pagel’s λ) tested PC1/PC2 vs trophic level + body size</a:t>
             </a:r>
           </a:p>
           <a:p>
@@ -3979,23 +3963,7 @@
                 </a:solidFill>
                 <a:latin typeface="Calibri"/>
               </a:rPr>
-              <a:t>• Phylogenetic generalized least squares (PGLS with Pagel’s λ) tested whether trophic level and body size predict PC1 and PC2 scores.</a:t>
-            </a:r>
-          </a:p>
-          <a:p>
-            <a:pPr algn="l">
-              <a:spcBef>
-                <a:spcPts val="600"/>
-              </a:spcBef>
-            </a:pPr>
-            <a:r>
-              <a:rPr sz="2400" b="0" i="0">
-                <a:solidFill>
-                  <a:srgbClr val="333333"/>
-                </a:solidFill>
-                <a:latin typeface="Calibri"/>
-              </a:rPr>
-              <a:t>• Trophic level and body size data were obtained from FishBase via rfishbase.</a:t>
+              <a:t>• 109-tip chronogram from Alfaro et al. (2019)</a:t>
             </a:r>
           </a:p>
         </p:txBody>
@@ -4080,14 +4048,14 @@
       </p:sp>
       <p:sp>
         <p:nvSpPr>
-          <p:cNvPr id="26" name="TextBox 25"/>
+          <p:cNvPr id="25" name="TextBox 24"/>
           <p:cNvSpPr txBox="1"/>
           <p:nvPr/>
         </p:nvSpPr>
         <p:spPr>
           <a:xfrm>
-            <a:off x="13258800" y="12481560"/>
-            <a:ext cx="8229600" cy="457200"/>
+            <a:off x="13350240" y="5166359"/>
+            <a:ext cx="1645920" cy="365760"/>
           </a:xfrm>
           <a:prstGeom prst="rect">
             <a:avLst/>
@@ -4102,6 +4070,41 @@
           <a:p>
             <a:pPr algn="l"/>
             <a:r>
+              <a:rPr sz="1800" b="1" i="0">
+                <a:solidFill>
+                  <a:srgbClr val="003B5C"/>
+                </a:solidFill>
+                <a:latin typeface="Calibri"/>
+              </a:rPr>
+              <a:t>PANEL A</a:t>
+            </a:r>
+          </a:p>
+        </p:txBody>
+      </p:sp>
+      <p:sp>
+        <p:nvSpPr>
+          <p:cNvPr id="27" name="TextBox 26"/>
+          <p:cNvSpPr txBox="1"/>
+          <p:nvPr/>
+        </p:nvSpPr>
+        <p:spPr>
+          <a:xfrm>
+            <a:off x="13258800" y="12481560"/>
+            <a:ext cx="8229600" cy="457200"/>
+          </a:xfrm>
+          <a:prstGeom prst="rect">
+            <a:avLst/>
+          </a:prstGeom>
+          <a:noFill/>
+        </p:spPr>
+        <p:txBody>
+          <a:bodyPr wrap="square" lIns="45720" rIns="45720">
+            <a:spAutoFit/>
+          </a:bodyPr>
+          <a:lstStyle/>
+          <a:p>
+            <a:pPr algn="l"/>
+            <a:r>
               <a:rPr sz="2000" b="0" i="1">
                 <a:solidFill>
                   <a:srgbClr val="333333"/>
@@ -4121,8 +4124,8 @@
         </p:nvSpPr>
         <p:spPr>
           <a:xfrm>
-            <a:off x="22402800" y="12481560"/>
-            <a:ext cx="9144000" cy="457200"/>
+            <a:off x="22494240" y="5166359"/>
+            <a:ext cx="1645920" cy="365760"/>
           </a:xfrm>
           <a:prstGeom prst="rect">
             <a:avLst/>
@@ -4137,6 +4140,41 @@
           <a:p>
             <a:pPr algn="l"/>
             <a:r>
+              <a:rPr sz="1800" b="1" i="0">
+                <a:solidFill>
+                  <a:srgbClr val="003B5C"/>
+                </a:solidFill>
+                <a:latin typeface="Calibri"/>
+              </a:rPr>
+              <a:t>PANEL B</a:t>
+            </a:r>
+          </a:p>
+        </p:txBody>
+      </p:sp>
+      <p:sp>
+        <p:nvSpPr>
+          <p:cNvPr id="31" name="TextBox 30"/>
+          <p:cNvSpPr txBox="1"/>
+          <p:nvPr/>
+        </p:nvSpPr>
+        <p:spPr>
+          <a:xfrm>
+            <a:off x="22402800" y="12481560"/>
+            <a:ext cx="9144000" cy="457200"/>
+          </a:xfrm>
+          <a:prstGeom prst="rect">
+            <a:avLst/>
+          </a:prstGeom>
+          <a:noFill/>
+        </p:spPr>
+        <p:txBody>
+          <a:bodyPr wrap="square" lIns="45720" rIns="45720">
+            <a:spAutoFit/>
+          </a:bodyPr>
+          <a:lstStyle/>
+          <a:p>
+            <a:pPr algn="l"/>
+            <a:r>
               <a:rPr sz="2000" b="0" i="1">
                 <a:solidFill>
                   <a:srgbClr val="333333"/>
@@ -4150,14 +4188,14 @@
       </p:sp>
       <p:sp>
         <p:nvSpPr>
-          <p:cNvPr id="32" name="TextBox 31"/>
+          <p:cNvPr id="33" name="TextBox 32"/>
           <p:cNvSpPr txBox="1"/>
           <p:nvPr/>
         </p:nvSpPr>
         <p:spPr>
           <a:xfrm>
-            <a:off x="13716000" y="25191720"/>
-            <a:ext cx="17373600" cy="457200"/>
+            <a:off x="13807440" y="13304520"/>
+            <a:ext cx="1645920" cy="365760"/>
           </a:xfrm>
           <a:prstGeom prst="rect">
             <a:avLst/>
@@ -4172,6 +4210,41 @@
           <a:p>
             <a:pPr algn="l"/>
             <a:r>
+              <a:rPr sz="1800" b="1" i="0">
+                <a:solidFill>
+                  <a:srgbClr val="003B5C"/>
+                </a:solidFill>
+                <a:latin typeface="Calibri"/>
+              </a:rPr>
+              <a:t>PANEL C</a:t>
+            </a:r>
+          </a:p>
+        </p:txBody>
+      </p:sp>
+      <p:sp>
+        <p:nvSpPr>
+          <p:cNvPr id="35" name="TextBox 34"/>
+          <p:cNvSpPr txBox="1"/>
+          <p:nvPr/>
+        </p:nvSpPr>
+        <p:spPr>
+          <a:xfrm>
+            <a:off x="13716000" y="25191720"/>
+            <a:ext cx="17373600" cy="457200"/>
+          </a:xfrm>
+          <a:prstGeom prst="rect">
+            <a:avLst/>
+          </a:prstGeom>
+          <a:noFill/>
+        </p:spPr>
+        <p:txBody>
+          <a:bodyPr wrap="square" lIns="45720" rIns="45720">
+            <a:spAutoFit/>
+          </a:bodyPr>
+          <a:lstStyle/>
+          <a:p>
+            <a:pPr algn="l"/>
+            <a:r>
               <a:rPr sz="2000" b="0" i="1">
                 <a:solidFill>
                   <a:srgbClr val="333333"/>
@@ -4185,14 +4258,14 @@
       </p:sp>
       <p:sp>
         <p:nvSpPr>
-          <p:cNvPr id="35" name="TextBox 34"/>
+          <p:cNvPr id="37" name="TextBox 36"/>
           <p:cNvSpPr txBox="1"/>
           <p:nvPr/>
         </p:nvSpPr>
         <p:spPr>
           <a:xfrm>
-            <a:off x="32232600" y="11795760"/>
-            <a:ext cx="10972800" cy="457200"/>
+            <a:off x="32324040" y="4480559"/>
+            <a:ext cx="1645920" cy="365760"/>
           </a:xfrm>
           <a:prstGeom prst="rect">
             <a:avLst/>
@@ -4207,6 +4280,41 @@
           <a:p>
             <a:pPr algn="l"/>
             <a:r>
+              <a:rPr sz="1800" b="1" i="0">
+                <a:solidFill>
+                  <a:srgbClr val="003B5C"/>
+                </a:solidFill>
+                <a:latin typeface="Calibri"/>
+              </a:rPr>
+              <a:t>PANEL D</a:t>
+            </a:r>
+          </a:p>
+        </p:txBody>
+      </p:sp>
+      <p:sp>
+        <p:nvSpPr>
+          <p:cNvPr id="39" name="TextBox 38"/>
+          <p:cNvSpPr txBox="1"/>
+          <p:nvPr/>
+        </p:nvSpPr>
+        <p:spPr>
+          <a:xfrm>
+            <a:off x="32232600" y="11795760"/>
+            <a:ext cx="10972800" cy="457200"/>
+          </a:xfrm>
+          <a:prstGeom prst="rect">
+            <a:avLst/>
+          </a:prstGeom>
+          <a:noFill/>
+        </p:spPr>
+        <p:txBody>
+          <a:bodyPr wrap="square" lIns="45720" rIns="45720">
+            <a:spAutoFit/>
+          </a:bodyPr>
+          <a:lstStyle/>
+          <a:p>
+            <a:pPr algn="l"/>
+            <a:r>
               <a:rPr sz="2000" b="0" i="1">
                 <a:solidFill>
                   <a:srgbClr val="333333"/>
@@ -4220,7 +4328,7 @@
       </p:sp>
       <p:sp>
         <p:nvSpPr>
-          <p:cNvPr id="36" name="TextBox 35"/>
+          <p:cNvPr id="40" name="TextBox 39"/>
           <p:cNvSpPr txBox="1"/>
           <p:nvPr/>
         </p:nvSpPr>
@@ -4255,7 +4363,7 @@
       </p:sp>
       <p:sp>
         <p:nvSpPr>
-          <p:cNvPr id="37" name="Rectangle 36"/>
+          <p:cNvPr id="41" name="Rectangle 40"/>
           <p:cNvSpPr/>
           <p:nvPr/>
         </p:nvSpPr>
@@ -4298,7 +4406,7 @@
       </p:sp>
       <p:sp>
         <p:nvSpPr>
-          <p:cNvPr id="38" name="TextBox 37"/>
+          <p:cNvPr id="42" name="TextBox 41"/>
           <p:cNvSpPr txBox="1"/>
           <p:nvPr/>
         </p:nvSpPr>
@@ -4333,7 +4441,7 @@
                 </a:solidFill>
                 <a:latin typeface="Calibri"/>
               </a:rPr>
-              <a:t>• PC1 (pattern density) shows moderate phylogenetic signal, indicating that closely related butterflyfishes tend to share similar pattern complexity — consistent with Alfaro et al. (2019).</a:t>
+              <a:t>• PC1 (pattern density) shows moderate phylogenetic signal (K = [value]), indicating that closely related butterflyfishes share similar pattern complexity.</a:t>
             </a:r>
           </a:p>
           <a:p>
@@ -4349,7 +4457,7 @@
                 </a:solidFill>
                 <a:latin typeface="Calibri"/>
               </a:rPr>
-              <a:t>• The PGLS analysis reveals that trophic level is a significant predictor of PC2 (color diversity) after controlling for phylogeny, suggesting that dietary ecology shapes chromatic diversity in this clade.</a:t>
+              <a:t>• Trophic level significantly predicts PC2 (chromatic diversity) after phylogenetic correction, suggesting that dietary ecology shapes color diversity in this clade.</a:t>
             </a:r>
           </a:p>
           <a:p>
@@ -4365,14 +4473,14 @@
                 </a:solidFill>
                 <a:latin typeface="Calibri"/>
               </a:rPr>
-              <a:t>• The phylomorphospace reveals extensive overlap among genera in PC1–PC2 space, with several instances of convergent color patterns among distantly related lineages.</a:t>
-            </a:r>
-          </a:p>
-        </p:txBody>
-      </p:sp>
-      <p:sp>
-        <p:nvSpPr>
-          <p:cNvPr id="39" name="TextBox 38"/>
+              <a:t>• Body size does not predict color variation, ruling out simple allometric scaling as the driver.</a:t>
+            </a:r>
+          </a:p>
+        </p:txBody>
+      </p:sp>
+      <p:sp>
+        <p:nvSpPr>
+          <p:cNvPr id="43" name="TextBox 42"/>
           <p:cNvSpPr txBox="1"/>
           <p:nvPr/>
         </p:nvSpPr>
@@ -4407,7 +4515,7 @@
       </p:sp>
       <p:sp>
         <p:nvSpPr>
-          <p:cNvPr id="40" name="Rectangle 39"/>
+          <p:cNvPr id="44" name="Rectangle 43"/>
           <p:cNvSpPr/>
           <p:nvPr/>
         </p:nvSpPr>
@@ -4450,7 +4558,7 @@
       </p:sp>
       <p:sp>
         <p:nvSpPr>
-          <p:cNvPr id="41" name="TextBox 40"/>
+          <p:cNvPr id="45" name="TextBox 44"/>
           <p:cNvSpPr txBox="1"/>
           <p:nvPr/>
         </p:nvSpPr>
@@ -4485,7 +4593,7 @@
                 </a:solidFill>
                 <a:latin typeface="Calibri"/>
               </a:rPr>
-              <a:t>• Color-pattern complexity in butterflyfishes is moderately phylogenetically conserved but not strongly predicted by body size.</a:t>
+              <a:t>• Color-pattern structure in butterflyfishes is phylogenetically patterned, with closely related species sharing similar designs.</a:t>
             </a:r>
           </a:p>
           <a:p>
@@ -4501,7 +4609,7 @@
                 </a:solidFill>
                 <a:latin typeface="Calibri"/>
               </a:rPr>
-              <a:t>• Trophic ecology significantly predicts chromatic diversity (PC2), consistent with the hypothesis that diet-associated habitat use influences visual signaling.</a:t>
+              <a:t>• Trophic ecology may explain part of chromatic variation (PC2), but the effect is modest.</a:t>
             </a:r>
           </a:p>
           <a:p>
@@ -4517,14 +4625,14 @@
                 </a:solidFill>
                 <a:latin typeface="Calibri"/>
               </a:rPr>
-              <a:t>• These results support a model of constrained diversification where evolutionary history sets the broad pattern and ecology fine-tunes the details.</a:t>
-            </a:r>
-          </a:p>
-        </p:txBody>
-      </p:sp>
-      <p:sp>
-        <p:nvSpPr>
-          <p:cNvPr id="42" name="TextBox 41"/>
+              <a:t>• The decoupling of phylogenetic signal and ecological prediction mirrors findings in other reef fish clades (Alfaro et al. 2019).</a:t>
+            </a:r>
+          </a:p>
+        </p:txBody>
+      </p:sp>
+      <p:sp>
+        <p:nvSpPr>
+          <p:cNvPr id="46" name="TextBox 45"/>
           <p:cNvSpPr txBox="1"/>
           <p:nvPr/>
         </p:nvSpPr>
@@ -4559,7 +4667,7 @@
       </p:sp>
       <p:sp>
         <p:nvSpPr>
-          <p:cNvPr id="43" name="Rectangle 42"/>
+          <p:cNvPr id="47" name="Rectangle 46"/>
           <p:cNvSpPr/>
           <p:nvPr/>
         </p:nvSpPr>
@@ -4602,7 +4710,7 @@
       </p:sp>
       <p:sp>
         <p:nvSpPr>
-          <p:cNvPr id="44" name="TextBox 43"/>
+          <p:cNvPr id="48" name="TextBox 47"/>
           <p:cNvSpPr txBox="1"/>
           <p:nvPr/>
         </p:nvSpPr>
@@ -4644,7 +4752,7 @@
       </p:sp>
       <p:sp>
         <p:nvSpPr>
-          <p:cNvPr id="45" name="TextBox 44"/>
+          <p:cNvPr id="49" name="TextBox 48"/>
           <p:cNvSpPr txBox="1"/>
           <p:nvPr/>
         </p:nvSpPr>
@@ -4679,7 +4787,7 @@
       </p:sp>
       <p:sp>
         <p:nvSpPr>
-          <p:cNvPr id="46" name="Rectangle 45"/>
+          <p:cNvPr id="50" name="Rectangle 49"/>
           <p:cNvSpPr/>
           <p:nvPr/>
         </p:nvSpPr>
@@ -4722,7 +4830,7 @@
       </p:sp>
       <p:sp>
         <p:nvSpPr>
-          <p:cNvPr id="47" name="TextBox 46"/>
+          <p:cNvPr id="51" name="TextBox 50"/>
           <p:cNvSpPr txBox="1"/>
           <p:nvPr/>
         </p:nvSpPr>
@@ -4757,7 +4865,7 @@
                 </a:solidFill>
                 <a:latin typeface="Calibri"/>
               </a:rPr>
-              <a:t>Alfaro, M.E. et al. (2019). Ichthyology &amp; Herpetology.</a:t>
+              <a:t>Alfaro, M.E., Karan, E.A., Schwartz, S.T., &amp; Shultz, A.J. (2019). Integrative and Comparative Biology, 59(3), 604–615. doi:10.1093/icb/icz119</a:t>
             </a:r>
             <a:r>
               <a:rPr sz="1800" b="0" i="0">
@@ -4840,7 +4948,42 @@
       </p:sp>
       <p:sp>
         <p:nvSpPr>
-          <p:cNvPr id="48" name="Rectangle 47"/>
+          <p:cNvPr id="52" name="TextBox 51"/>
+          <p:cNvSpPr txBox="1"/>
+          <p:nvPr/>
+        </p:nvSpPr>
+        <p:spPr>
+          <a:xfrm>
+            <a:off x="685800" y="31089600"/>
+            <a:ext cx="42519600" cy="365760"/>
+          </a:xfrm>
+          <a:prstGeom prst="rect">
+            <a:avLst/>
+          </a:prstGeom>
+          <a:noFill/>
+        </p:spPr>
+        <p:txBody>
+          <a:bodyPr wrap="square" lIns="45720" rIns="45720">
+            <a:spAutoFit/>
+          </a:bodyPr>
+          <a:lstStyle/>
+          <a:p>
+            <a:pPr algn="ctr"/>
+            <a:r>
+              <a:rPr sz="1600" b="1" i="1">
+                <a:solidFill>
+                  <a:srgbClr val="2774AE"/>
+                </a:solidFill>
+                <a:latin typeface="Calibri"/>
+              </a:rPr>
+              <a:t>REMINDER: Delete all [bracketed placeholder text] before printing. Save as PDF for the print shop.</a:t>
+            </a:r>
+          </a:p>
+        </p:txBody>
+      </p:sp>
+      <p:sp>
+        <p:nvSpPr>
+          <p:cNvPr id="53" name="Rectangle 52"/>
           <p:cNvSpPr/>
           <p:nvPr/>
         </p:nvSpPr>
@@ -4883,7 +5026,7 @@
       </p:sp>
       <p:sp>
         <p:nvSpPr>
-          <p:cNvPr id="49" name="TextBox 48"/>
+          <p:cNvPr id="54" name="TextBox 53"/>
           <p:cNvSpPr txBox="1"/>
           <p:nvPr/>
         </p:nvSpPr>
@@ -4918,7 +5061,7 @@
       </p:sp>
       <p:sp>
         <p:nvSpPr>
-          <p:cNvPr id="50" name="TextBox 49"/>
+          <p:cNvPr id="55" name="TextBox 54"/>
           <p:cNvSpPr txBox="1"/>
           <p:nvPr/>
         </p:nvSpPr>
@@ -4951,9 +5094,87 @@
           </a:p>
         </p:txBody>
       </p:sp>
+      <p:sp>
+        <p:nvSpPr>
+          <p:cNvPr id="56" name="Rectangle 55"/>
+          <p:cNvSpPr/>
+          <p:nvPr/>
+        </p:nvSpPr>
+        <p:spPr>
+          <a:xfrm>
+            <a:off x="13258800" y="25146000"/>
+            <a:ext cx="18288000" cy="1097280"/>
+          </a:xfrm>
+          <a:prstGeom prst="rect">
+            <a:avLst/>
+          </a:prstGeom>
+          <a:solidFill>
+            <a:srgbClr val="FFD100"/>
+          </a:solidFill>
+          <a:ln>
+            <a:noFill/>
+          </a:ln>
+        </p:spPr>
+        <p:style>
+          <a:lnRef idx="1">
+            <a:schemeClr val="accent1"/>
+          </a:lnRef>
+          <a:fillRef idx="3">
+            <a:schemeClr val="accent1"/>
+          </a:fillRef>
+          <a:effectRef idx="2">
+            <a:schemeClr val="accent1"/>
+          </a:effectRef>
+          <a:fontRef idx="minor">
+            <a:schemeClr val="lt1"/>
+          </a:fontRef>
+        </p:style>
+        <p:txBody>
+          <a:bodyPr rtlCol="0" anchor="ctr"/>
+          <a:lstStyle/>
+          <a:p>
+            <a:pPr algn="ctr"/>
+          </a:p>
+        </p:txBody>
+      </p:sp>
+      <p:sp>
+        <p:nvSpPr>
+          <p:cNvPr id="57" name="TextBox 56"/>
+          <p:cNvSpPr txBox="1"/>
+          <p:nvPr/>
+        </p:nvSpPr>
+        <p:spPr>
+          <a:xfrm>
+            <a:off x="13441680" y="25283160"/>
+            <a:ext cx="17922240" cy="822959"/>
+          </a:xfrm>
+          <a:prstGeom prst="rect">
+            <a:avLst/>
+          </a:prstGeom>
+          <a:noFill/>
+        </p:spPr>
+        <p:txBody>
+          <a:bodyPr wrap="square">
+            <a:spAutoFit/>
+          </a:bodyPr>
+          <a:lstStyle/>
+          <a:p>
+            <a:pPr algn="ctr"/>
+            <a:r>
+              <a:rPr sz="2200" b="1" i="0">
+                <a:solidFill>
+                  <a:srgbClr val="003B5C"/>
+                </a:solidFill>
+                <a:latin typeface="Calibri"/>
+              </a:rPr>
+              <a:t>MAIN RESULT: Color-pattern structure is phylogenetically conserved, with limited ecological prediction — trophic level modestly predicts chromatic diversity but not pattern complexity.</a:t>
+            </a:r>
+          </a:p>
+        </p:txBody>
+      </p:sp>
       <p:pic>
         <p:nvPicPr>
-          <p:cNvPr id="51" name="Picture 50" descr="image.png"/>
+          <p:cNvPr id="58" name="Picture 57" descr="image.png"/>
           <p:cNvPicPr>
             <a:picLocks noChangeAspect="1"/>
           </p:cNvPicPr>
@@ -4977,7 +5198,7 @@
       </p:pic>
       <p:pic>
         <p:nvPicPr>
-          <p:cNvPr id="52" name="Picture 51" descr="image.png"/>
+          <p:cNvPr id="59" name="Picture 58" descr="image.png"/>
           <p:cNvPicPr>
             <a:picLocks noChangeAspect="1"/>
           </p:cNvPicPr>
@@ -5001,7 +5222,7 @@
       </p:pic>
       <p:pic>
         <p:nvPicPr>
-          <p:cNvPr id="53" name="Picture 52" descr="image.png"/>
+          <p:cNvPr id="60" name="Picture 59" descr="image.png"/>
           <p:cNvPicPr>
             <a:picLocks noChangeAspect="1"/>
           </p:cNvPicPr>
@@ -5025,7 +5246,7 @@
       </p:pic>
       <p:pic>
         <p:nvPicPr>
-          <p:cNvPr id="54" name="Picture 53" descr="image.png"/>
+          <p:cNvPr id="61" name="Picture 60" descr="image.png"/>
           <p:cNvPicPr>
             <a:picLocks noChangeAspect="1"/>
           </p:cNvPicPr>

</xml_diff>